<commit_message>
docs: set Himanshu Goyal (24BDA70369) as sole author and update academic session to 2026-2027 across README, DOCX report, and PPTX presentation
</commit_message>
<xml_diff>
--- a/TRAIN_TICKET_BOOKING_SYSTEM_PRESENTATION.pptx
+++ b/TRAIN_TICKET_BOOKING_SYSTEM_PRESENTATION.pptx
@@ -3371,7 +3371,7 @@
                   <a:srgbClr val="FFFFFF"/>
                 </a:solidFill>
               </a:rPr>
-              <a:t>HIMANSHU GOYAL  (24BDA70369)                              Er. Dheeresh Aggarwal
+              <a:t>HIMANSHU GOYAL (Sole Author)                              Er. Dheeresh Aggarwal
 </a:t>
             </a:r>
             <a:r>
@@ -3380,7 +3380,7 @@
                   <a:srgbClr val="FFFFFF"/>
                 </a:solidFill>
               </a:rPr>
-              <a:t>ABHISHEK YADAV  (24BDA70298)                              Assistant Professor, Dept of AIT-CSE</a:t>
+              <a:t>UID: 24BDA70369 • Session: 2026–2027                     Assistant Professor, Dept of AIT-CSE</a:t>
             </a:r>
           </a:p>
         </p:txBody>
@@ -3586,7 +3586,7 @@
                   <a:srgbClr val="475569"/>
                 </a:solidFill>
               </a:rPr>
-              <a:t>Chandigarh University • Dept of AIT-CSE • Himanshu Goyal (24BDA70369) &amp; Abhishek Yadav (24BDA70298) • Supervisor: Er. Dheeresh Aggarwal</a:t>
+              <a:t>Chandigarh University • Dept of AIT-CSE • Himanshu Goyal (24BDA70369) • Supervisor: Er. Dheeresh Aggarwal</a:t>
             </a:r>
           </a:p>
         </p:txBody>
@@ -4141,7 +4141,7 @@
                   <a:srgbClr val="475569"/>
                 </a:solidFill>
               </a:rPr>
-              <a:t>Chandigarh University • Dept of AIT-CSE • Himanshu Goyal (24BDA70369) &amp; Abhishek Yadav (24BDA70298) • Supervisor: Er. Dheeresh Aggarwal</a:t>
+              <a:t>Chandigarh University • Dept of AIT-CSE • Himanshu Goyal (24BDA70369) • Supervisor: Er. Dheeresh Aggarwal</a:t>
             </a:r>
           </a:p>
         </p:txBody>
@@ -4565,7 +4565,7 @@
                   <a:srgbClr val="475569"/>
                 </a:solidFill>
               </a:rPr>
-              <a:t>Chandigarh University • Dept of AIT-CSE • Himanshu Goyal (24BDA70369) &amp; Abhishek Yadav (24BDA70298) • Supervisor: Er. Dheeresh Aggarwal</a:t>
+              <a:t>Chandigarh University • Dept of AIT-CSE • Himanshu Goyal (24BDA70369) • Supervisor: Er. Dheeresh Aggarwal</a:t>
             </a:r>
           </a:p>
         </p:txBody>
@@ -4966,7 +4966,7 @@
                   <a:srgbClr val="475569"/>
                 </a:solidFill>
               </a:rPr>
-              <a:t>Chandigarh University • Dept of AIT-CSE • Himanshu Goyal (24BDA70369) &amp; Abhishek Yadav (24BDA70298) • Supervisor: Er. Dheeresh Aggarwal</a:t>
+              <a:t>Chandigarh University • Dept of AIT-CSE • Himanshu Goyal (24BDA70369) • Supervisor: Er. Dheeresh Aggarwal</a:t>
             </a:r>
           </a:p>
         </p:txBody>
@@ -5367,7 +5367,7 @@
                   <a:srgbClr val="475569"/>
                 </a:solidFill>
               </a:rPr>
-              <a:t>Chandigarh University • Dept of AIT-CSE • Himanshu Goyal (24BDA70369) &amp; Abhishek Yadav (24BDA70298) • Supervisor: Er. Dheeresh Aggarwal</a:t>
+              <a:t>Chandigarh University • Dept of AIT-CSE • Himanshu Goyal (24BDA70369) • Supervisor: Er. Dheeresh Aggarwal</a:t>
             </a:r>
           </a:p>
         </p:txBody>
@@ -5752,7 +5752,7 @@
                   <a:srgbClr val="475569"/>
                 </a:solidFill>
               </a:rPr>
-              <a:t>Chandigarh University • Dept of AIT-CSE • Himanshu Goyal (24BDA70369) &amp; Abhishek Yadav (24BDA70298) • Supervisor: Er. Dheeresh Aggarwal</a:t>
+              <a:t>Chandigarh University • Dept of AIT-CSE • Himanshu Goyal (24BDA70369) • Supervisor: Er. Dheeresh Aggarwal</a:t>
             </a:r>
           </a:p>
         </p:txBody>
@@ -6176,7 +6176,7 @@
                   <a:srgbClr val="475569"/>
                 </a:solidFill>
               </a:rPr>
-              <a:t>Chandigarh University • Dept of AIT-CSE • Himanshu Goyal (24BDA70369) &amp; Abhishek Yadav (24BDA70298) • Supervisor: Er. Dheeresh Aggarwal</a:t>
+              <a:t>Chandigarh University • Dept of AIT-CSE • Himanshu Goyal (24BDA70369) • Supervisor: Er. Dheeresh Aggarwal</a:t>
             </a:r>
           </a:p>
         </p:txBody>
@@ -6600,7 +6600,7 @@
                   <a:srgbClr val="475569"/>
                 </a:solidFill>
               </a:rPr>
-              <a:t>Chandigarh University • Dept of AIT-CSE • Himanshu Goyal (24BDA70369) &amp; Abhishek Yadav (24BDA70298) • Supervisor: Er. Dheeresh Aggarwal</a:t>
+              <a:t>Chandigarh University • Dept of AIT-CSE • Himanshu Goyal (24BDA70369) • Supervisor: Er. Dheeresh Aggarwal</a:t>
             </a:r>
           </a:p>
         </p:txBody>
@@ -7286,7 +7286,7 @@
                   <a:srgbClr val="475569"/>
                 </a:solidFill>
               </a:rPr>
-              <a:t>Chandigarh University • Dept of AIT-CSE • Himanshu Goyal (24BDA70369) &amp; Abhishek Yadav (24BDA70298) • Supervisor: Er. Dheeresh Aggarwal</a:t>
+              <a:t>Chandigarh University • Dept of AIT-CSE • Himanshu Goyal (24BDA70369) • Supervisor: Er. Dheeresh Aggarwal</a:t>
             </a:r>
           </a:p>
         </p:txBody>
@@ -8050,7 +8050,7 @@
                   <a:srgbClr val="475569"/>
                 </a:solidFill>
               </a:rPr>
-              <a:t>Chandigarh University • Dept of AIT-CSE • Himanshu Goyal (24BDA70369) &amp; Abhishek Yadav (24BDA70298) • Supervisor: Er. Dheeresh Aggarwal</a:t>
+              <a:t>Chandigarh University • Dept of AIT-CSE • Himanshu Goyal (24BDA70369) • Supervisor: Er. Dheeresh Aggarwal</a:t>
             </a:r>
           </a:p>
         </p:txBody>
@@ -8367,8 +8367,8 @@
                   <a:srgbClr val="CBD5E1"/>
                 </a:solidFill>
               </a:rPr>
-              <a:t>Himanshu Goyal (24BDA70369)
-Abhishek Yadav (24BDA70298)
+              <a:t>Himanshu Goyal (UID: 24BDA70369)
+Sole Author • Academic Session: 2026 – 2027
 Supervisor: Er. Dheeresh Aggarwal
 Dept of AIT-CSE, Chandigarh University</a:t>
             </a:r>
@@ -8576,7 +8576,7 @@
                   <a:srgbClr val="475569"/>
                 </a:solidFill>
               </a:rPr>
-              <a:t>Chandigarh University • Dept of AIT-CSE • Himanshu Goyal (24BDA70369) &amp; Abhishek Yadav (24BDA70298) • Supervisor: Er. Dheeresh Aggarwal</a:t>
+              <a:t>Chandigarh University • Dept of AIT-CSE • Himanshu Goyal (24BDA70369) • Supervisor: Er. Dheeresh Aggarwal</a:t>
             </a:r>
           </a:p>
         </p:txBody>
@@ -9550,7 +9550,7 @@
                   <a:srgbClr val="475569"/>
                 </a:solidFill>
               </a:rPr>
-              <a:t>Chandigarh University • Dept of AIT-CSE • Himanshu Goyal (24BDA70369) &amp; Abhishek Yadav (24BDA70298) • Supervisor: Er. Dheeresh Aggarwal</a:t>
+              <a:t>Chandigarh University • Dept of AIT-CSE • Himanshu Goyal (24BDA70369) • Supervisor: Er. Dheeresh Aggarwal</a:t>
             </a:r>
           </a:p>
         </p:txBody>
@@ -10121,7 +10121,7 @@
                   <a:srgbClr val="475569"/>
                 </a:solidFill>
               </a:rPr>
-              <a:t>Chandigarh University • Dept of AIT-CSE • Himanshu Goyal (24BDA70369) &amp; Abhishek Yadav (24BDA70298) • Supervisor: Er. Dheeresh Aggarwal</a:t>
+              <a:t>Chandigarh University • Dept of AIT-CSE • Himanshu Goyal (24BDA70369) • Supervisor: Er. Dheeresh Aggarwal</a:t>
             </a:r>
           </a:p>
         </p:txBody>
@@ -10622,7 +10622,7 @@
                   <a:srgbClr val="475569"/>
                 </a:solidFill>
               </a:rPr>
-              <a:t>Chandigarh University • Dept of AIT-CSE • Himanshu Goyal (24BDA70369) &amp; Abhishek Yadav (24BDA70298) • Supervisor: Er. Dheeresh Aggarwal</a:t>
+              <a:t>Chandigarh University • Dept of AIT-CSE • Himanshu Goyal (24BDA70369) • Supervisor: Er. Dheeresh Aggarwal</a:t>
             </a:r>
           </a:p>
         </p:txBody>
@@ -11386,7 +11386,7 @@
                   <a:srgbClr val="475569"/>
                 </a:solidFill>
               </a:rPr>
-              <a:t>Chandigarh University • Dept of AIT-CSE • Himanshu Goyal (24BDA70369) &amp; Abhishek Yadav (24BDA70298) • Supervisor: Er. Dheeresh Aggarwal</a:t>
+              <a:t>Chandigarh University • Dept of AIT-CSE • Himanshu Goyal (24BDA70369) • Supervisor: Er. Dheeresh Aggarwal</a:t>
             </a:r>
           </a:p>
         </p:txBody>
@@ -12296,7 +12296,7 @@
                   <a:srgbClr val="475569"/>
                 </a:solidFill>
               </a:rPr>
-              <a:t>Chandigarh University • Dept of AIT-CSE • Himanshu Goyal (24BDA70369) &amp; Abhishek Yadav (24BDA70298) • Supervisor: Er. Dheeresh Aggarwal</a:t>
+              <a:t>Chandigarh University • Dept of AIT-CSE • Himanshu Goyal (24BDA70369) • Supervisor: Er. Dheeresh Aggarwal</a:t>
             </a:r>
           </a:p>
         </p:txBody>
@@ -12697,7 +12697,7 @@
                   <a:srgbClr val="475569"/>
                 </a:solidFill>
               </a:rPr>
-              <a:t>Chandigarh University • Dept of AIT-CSE • Himanshu Goyal (24BDA70369) &amp; Abhishek Yadav (24BDA70298) • Supervisor: Er. Dheeresh Aggarwal</a:t>
+              <a:t>Chandigarh University • Dept of AIT-CSE • Himanshu Goyal (24BDA70369) • Supervisor: Er. Dheeresh Aggarwal</a:t>
             </a:r>
           </a:p>
         </p:txBody>
@@ -13279,7 +13279,7 @@
                   <a:srgbClr val="475569"/>
                 </a:solidFill>
               </a:rPr>
-              <a:t>Chandigarh University • Dept of AIT-CSE • Himanshu Goyal (24BDA70369) &amp; Abhishek Yadav (24BDA70298) • Supervisor: Er. Dheeresh Aggarwal</a:t>
+              <a:t>Chandigarh University • Dept of AIT-CSE • Himanshu Goyal (24BDA70369) • Supervisor: Er. Dheeresh Aggarwal</a:t>
             </a:r>
           </a:p>
         </p:txBody>

</xml_diff>